<commit_message>
Ajuste no logging.warning do main.py, incluindo a opcao 4 na saida
</commit_message>
<xml_diff>
--- a/config/2 - Apresentacao Trabalho Final 3.pptx
+++ b/config/2 - Apresentacao Trabalho Final 3.pptx
@@ -3134,7 +3134,7 @@
           </a:prstGeom>
           <a:extLst>
             <a:ext uri="{C572A759-6A51-4108-AA02-DFA0A04FC94B}">
-              <ma14:wrappingTextBoxFlag xmlns="" xmlns:ma14="http://schemas.microsoft.com/office/mac/drawingml/2011/main" val="0"/>
+              <ma14:wrappingTextBoxFlag xmlns:ma14="http://schemas.microsoft.com/office/mac/drawingml/2011/main" xmlns="" val="0"/>
             </a:ext>
           </a:extLst>
         </p:spPr>
@@ -3300,7 +3300,7 @@
           </a:prstGeom>
           <a:extLst>
             <a:ext uri="{C572A759-6A51-4108-AA02-DFA0A04FC94B}">
-              <ma14:wrappingTextBoxFlag xmlns:ma14="http://schemas.microsoft.com/office/mac/drawingml/2011/main" xmlns="" val="0"/>
+              <ma14:wrappingTextBoxFlag xmlns="" xmlns:ma14="http://schemas.microsoft.com/office/mac/drawingml/2011/main" val="0"/>
             </a:ext>
           </a:extLst>
         </p:spPr>
@@ -3396,7 +3396,7 @@
           </a:prstGeom>
           <a:extLst>
             <a:ext uri="{C572A759-6A51-4108-AA02-DFA0A04FC94B}">
-              <ma14:wrappingTextBoxFlag xmlns="" xmlns:ma14="http://schemas.microsoft.com/office/mac/drawingml/2011/main" val="0"/>
+              <ma14:wrappingTextBoxFlag xmlns:ma14="http://schemas.microsoft.com/office/mac/drawingml/2011/main" xmlns="" val="0"/>
             </a:ext>
           </a:extLst>
         </p:spPr>
@@ -8389,7 +8389,7 @@
           </a:prstGeom>
           <a:extLst>
             <a:ext uri="{C572A759-6A51-4108-AA02-DFA0A04FC94B}">
-              <ma14:wrappingTextBoxFlag xmlns="" xmlns:ma14="http://schemas.microsoft.com/office/mac/drawingml/2011/main" val="0"/>
+              <ma14:wrappingTextBoxFlag xmlns:ma14="http://schemas.microsoft.com/office/mac/drawingml/2011/main" xmlns="" val="0"/>
             </a:ext>
           </a:extLst>
         </p:spPr>
@@ -10302,7 +10302,7 @@
           </a:prstGeom>
           <a:extLst>
             <a:ext uri="{C572A759-6A51-4108-AA02-DFA0A04FC94B}">
-              <ma14:wrappingTextBoxFlag xmlns="" xmlns:ma14="http://schemas.microsoft.com/office/mac/drawingml/2011/main" val="0"/>
+              <ma14:wrappingTextBoxFlag xmlns:ma14="http://schemas.microsoft.com/office/mac/drawingml/2011/main" xmlns="" val="0"/>
             </a:ext>
           </a:extLst>
         </p:spPr>
@@ -10546,7 +10546,7 @@
           </a:prstGeom>
           <a:extLst>
             <a:ext uri="{C572A759-6A51-4108-AA02-DFA0A04FC94B}">
-              <ma14:wrappingTextBoxFlag xmlns:ma14="http://schemas.microsoft.com/office/mac/drawingml/2011/main" xmlns="" val="0"/>
+              <ma14:wrappingTextBoxFlag xmlns="" xmlns:ma14="http://schemas.microsoft.com/office/mac/drawingml/2011/main" val="0"/>
             </a:ext>
           </a:extLst>
         </p:spPr>

</xml_diff>